<commit_message>
Decks: rename DP2 to Prefill/Decode execution planning wording
- DP0-slides, DP-memory-backend-if: DP2 slides (title, problem, design issue, Cost(n_p,n_d), planner name, Q1/Q2, tradeoff TPOT row), cover table, DP3-background copy slide, slide-14 notes
- DP4/DP3 drafts: Prefill/Decode wording, ExecutionPlanner label

Co-Authored-By: Claude Sonnet 5.5 <noreply@anthropic.com>
Claude-Session: https://claude.ai/code/session_012rJVLGpWwhEiZ4LApFUU27
</commit_message>
<xml_diff>
--- a/doc-mk/DP4/DP4-slides-draft.pptx
+++ b/doc-mk/DP4/DP4-slides-draft.pptx
@@ -510,7 +510,7 @@
           </a:p>
           <a:p>
             <a:r>
-              <a:t>P/D 분리 구조에서는 Prefill을 P 노드에서 할지 D 노드에서 할지를 매번 골라야 합니다. DP2가 이동 비용(Tmove), 연산 비용(Tprefill), 대기 비용(Tqueue)으로 이 선택을 최적화합니다.</a:t>
+              <a:t>P/D 분리 구조에서는 Prefill을 어디서 실행하고 Decode를 어디서 시작할지를 매번 골라야 합니다. DP2가 이동 비용(Tmove), 연산 비용(Tprefill), 대기 비용(Tqueue), Decode 노드 간섭(ΔTPOT)으로 이 선택을 최적화합니다.</a:t>
             </a:r>
           </a:p>
           <a:p>
@@ -610,7 +610,7 @@
           </a:p>
           <a:p>
             <a:r>
-              <a:t>DP2는 P/D 노드 중 어디서 Prefill을 실행할지를 비용(Tmove, Tprefill, Tqueue)으로 고르지만 노드 간 KV 전송 비용 자체는 줄이지 못합니다. DP4는 이 전송 구조를 다룹니다. 위쪽 DP2의 Planner가 두 안에서 모두 비용 계산을 하고, 그 입력이 되는 위치와 이동 비용이 두 안에서 서로 다른 방식으로 제공됩니다.</a:t>
+              <a:t>DP2는 P/D 노드 중 어디서 Prefill을 실행하고 Decode를 시작할지를 비용(Tmove, Tprefill, Tqueue, ΔTPOT)으로 고르지만 노드 간 KV 전송 비용 자체는 줄이지 못합니다. DP4는 이 전송 구조를 다룹니다. 위쪽 DP2의 Planner가 두 안에서 모두 비용 계산을 하고, 그 입력이 되는 위치와 이동 비용이 두 안에서 서로 다른 방식으로 제공됩니다.</a:t>
             </a:r>
           </a:p>
           <a:p>
@@ -5093,7 +5093,7 @@
                 </a:solidFill>
                 <a:latin typeface="맑은 고딕" panose="020B0503020000020004" pitchFamily="50" charset="-127"/>
               </a:rPr>
-              <a:t>P/D 분리 구조에서 Prefill 실행 노드는 KV 위치·노드 부하·이동 비용을 고려해 골라야 하며, DP2가 Tmove·Tprefill·Tqueue 비용으로 이를 최적화함</a:t>
+              <a:t>P/D 분리 구조에서 Prefill 실행 노드와 Decode 시작 노드는 KV 위치·노드 부하·이동 비용을 고려해 골라야 하며, DP2가 Tmove·Tprefill·Tqueue·ΔTPOT 비용으로 이를 최적화함</a:t>
             </a:r>
             <a:endParaRPr lang="en-US" altLang="ko-KR" sz="1200" dirty="0">
               <a:solidFill>
@@ -9098,7 +9098,7 @@
                 <a:latin typeface="맑은 고딕"/>
                 <a:ea typeface="맑은 고딕"/>
               </a:rPr>
-              <a:t>Prefill Execution Planner</a:t>
+              <a:t>Execution Planner</a:t>
             </a:r>
           </a:p>
           <a:p>
@@ -10765,7 +10765,7 @@
                 <a:latin typeface="맑은 고딕"/>
                 <a:ea typeface="맑은 고딕"/>
               </a:rPr>
-              <a:t>Prefill Execution Planner</a:t>
+              <a:t>Execution Planner</a:t>
             </a:r>
           </a:p>
           <a:p>

</xml_diff>